<commit_message>
Reframe business case: GreenGuard as vision + MLOps platform for chemical-free weeding robots
Stronger, defensible narrative tied to herbicide bans (e.g. France Loi Labbe) and the autonomous-weeding market, with the MLOps loop (drift + retraining + monitoring) justified as the product's reliability backbone. Adds a business-outcome -> ML-metric -> monitoring-signal mapping and an indicative business case to the cahier des charges. Regenerated presentation.pptx (18 slides) and cahier_des_charges.docx; aligned the CI/CD narrative with the new manifest-validation job.

Co-Authored-By: Claude Opus 4.8 (1M context) <noreply@anthropic.com>
</commit_message>
<xml_diff>
--- a/deliverables/presentation.pptx
+++ b/deliverables/presentation.pptx
@@ -1267,7 +1267,7 @@
               <a:rPr lang="en-US" dirty="0">
                 <a:latin typeface="Trebuchet MS"/>
               </a:rPr>
-              <a:t>GreenGuard: a weed-detection classifier delivered as a full MLOps loop, not just a model. 30s.</a:t>
+              <a:t>GreenGuard: the perception brain for autonomous chemical-free weeding robots, delivered as a full MLOps loop. 30s.</a:t>
             </a:r>
           </a:p>
         </p:txBody>
@@ -1383,7 +1383,7 @@
               <a:rPr lang="en-US" dirty="0">
                 <a:latin typeface="Trebuchet MS"/>
               </a:rPr>
-              <a:t>Three jobs: test, build, deploy. Deploy verifies rollout.</a:t>
+              <a:t>Three jobs: test, build, validate manifests (kubeconform). The manifests also run on Minikube locally.</a:t>
             </a:r>
           </a:p>
         </p:txBody>
@@ -36881,7 +36881,7 @@
           <a:p>
             <a:r>
               <a:rPr lang="en-US" dirty="0"/>
-              <a:t>Bloc 4 - AI Solutions - MLOps Dandelion Classifier</a:t>
+              <a:t>Bloc 4 - AI Solutions - Vision and MLOps for Chemical-Free Weeding Robots</a:t>
             </a:r>
           </a:p>
         </p:txBody>
@@ -37670,7 +37670,7 @@
           <a:p>
             <a:r>
               <a:rPr lang="en-US" dirty="0"/>
-              <a:t>Every push runs tests, builds the image and deploys to Kubernetes automatically</a:t>
+              <a:t>Every push runs tests, builds and publishes the image, and validates the deployment</a:t>
             </a:r>
           </a:p>
         </p:txBody>
@@ -38171,7 +38171,7 @@
                 </a:solidFill>
                 <a:latin typeface="Trebuchet MS"/>
               </a:rPr>
-              <a:t>3  Deploy</a:t>
+              <a:t>3  Validate</a:t>
             </a:r>
           </a:p>
         </p:txBody>
@@ -38209,7 +38209,7 @@
                 </a:solidFill>
                 <a:latin typeface="Trebuchet MS"/>
               </a:rPr>
-              <a:t>Start Minikube</a:t>
+              <a:t>kubeconform on manifests</a:t>
             </a:r>
           </a:p>
           <a:p>
@@ -38226,7 +38226,7 @@
                 </a:solidFill>
                 <a:latin typeface="Trebuchet MS"/>
               </a:rPr>
-              <a:t>kubectl apply manifests</a:t>
+              <a:t>Schema-checked, offline</a:t>
             </a:r>
           </a:p>
           <a:p>
@@ -38243,7 +38243,7 @@
                 </a:solidFill>
                 <a:latin typeface="Trebuchet MS"/>
               </a:rPr>
-              <a:t>Verify rollout status</a:t>
+              <a:t>Same manifests run on Minikube</a:t>
             </a:r>
           </a:p>
         </p:txBody>
@@ -38305,7 +38305,7 @@
                 </a:solidFill>
                 <a:latin typeface="Trebuchet MS"/>
               </a:rPr>
-              <a:t>GitHub Actions runs all three jobs on every push to main; the deploy job gates on a successful Kubernetes rollout.</a:t>
+              <a:t>GitHub Actions runs all three jobs on every push to main; the deploy stage schema-validates the Kubernetes manifests.</a:t>
             </a:r>
           </a:p>
         </p:txBody>
@@ -41261,7 +41261,7 @@
                           <a:latin typeface="Trebuchet MS"/>
                           <a:cs typeface="Trebuchet MS"/>
                         </a:rPr>
-                        <a:t>Herbicide over-treatment is wasteful and harmful</a:t>
+                        <a:t>Herbicide bans in public green spaces (e.g. France Loi Labbe)</a:t>
                       </a:r>
                     </a:p>
                   </a:txBody>
@@ -41297,7 +41297,7 @@
                           <a:latin typeface="Trebuchet MS"/>
                           <a:cs typeface="Trebuchet MS"/>
                         </a:rPr>
-                        <a:t>Common knowledge - lawn care practice</a:t>
+                        <a:t>French Loi Labbe / zero-phyto regulation</a:t>
                       </a:r>
                     </a:p>
                   </a:txBody>
@@ -41573,7 +41573,7 @@
                 </a:solidFill>
                 <a:latin typeface="Trebuchet MS"/>
               </a:rPr>
-              <a:t>Gardeners spray whole lawns to kill a few weeds. GreenGuard classifies a lawn photo as dandelion or grass so treatment can be targeted.</a:t>
+              <a:t>Herbicide is being banned (e.g. France's Loi Labbe) and manual weeding is scarce. Autonomous robots weed mechanically, but must tell a weed (dandelion) from the crop (grass) in real time.</a:t>
             </a:r>
           </a:p>
         </p:txBody>
@@ -41847,7 +41847,7 @@
           <a:p>
             <a:r>
               <a:rPr lang="en-US" dirty="0"/>
-              <a:t>Blanket herbicide wastes money and harms the environment; targeted spraying needs AI</a:t>
+              <a:t>Herbicide bans and labour shortages make autonomous, chemical-free weeding the goal</a:t>
             </a:r>
           </a:p>
         </p:txBody>
@@ -44179,7 +44179,7 @@
                 </a:solidFill>
                 <a:latin typeface="Trebuchet MS"/>
               </a:rPr>
-              <a:t>Over-treatment</a:t>
+              <a:t>Chemicals are being banned</a:t>
             </a:r>
           </a:p>
         </p:txBody>
@@ -44211,7 +44211,7 @@
                 </a:solidFill>
                 <a:latin typeface="Trebuchet MS"/>
               </a:rPr>
-              <a:t>Whole-lawn spraying applies chemicals where no weed exists, raising cost and runoff.</a:t>
+              <a:t>Rules like France's Loi Labbe forbid herbicide in public green spaces; organic forbids it too.</a:t>
             </a:r>
           </a:p>
         </p:txBody>
@@ -45195,7 +45195,7 @@
                 </a:solidFill>
                 <a:latin typeface="Trebuchet MS"/>
               </a:rPr>
-              <a:t>Targeting needs detection</a:t>
+              <a:t>Robots need to see</a:t>
             </a:r>
           </a:p>
         </p:txBody>
@@ -45227,7 +45227,7 @@
                 </a:solidFill>
                 <a:latin typeface="Trebuchet MS"/>
               </a:rPr>
-              <a:t>Spot-treatment first requires reliably telling a weed (dandelion) from grass in a photo.</a:t>
+              <a:t>A weeding robot must tell a weed (dandelion) from the crop (grass) in real time, or it cuts the wrong plant.</a:t>
             </a:r>
           </a:p>
         </p:txBody>
@@ -45974,7 +45974,7 @@
                 </a:solidFill>
                 <a:latin typeface="Trebuchet MS"/>
               </a:rPr>
-              <a:t>Manual is not scalable</a:t>
+              <a:t>Manual weeding does not scale</a:t>
             </a:r>
           </a:p>
         </p:txBody>
@@ -46006,7 +46006,7 @@
                 </a:solidFill>
                 <a:latin typeface="Trebuchet MS"/>
               </a:rPr>
-              <a:t>A person cannot inspect every patch; an automated, fast classifier is the enabler.</a:t>
+              <a:t>Hand-weeding is labour-scarce and costly; a fast, automated perception model is the enabler.</a:t>
             </a:r>
           </a:p>
         </p:txBody>
@@ -46068,7 +46068,7 @@
                 </a:solidFill>
                 <a:latin typeface="Trebuchet MS"/>
               </a:rPr>
-              <a:t>The AI component is a binary image classifier (dandelion vs grass), industrialised as a full MLOps solution.</a:t>
+              <a:t>GreenGuard is the robot's perception brain: a binary classifier (weed vs crop), industrialised as a full MLOps platform.</a:t>
             </a:r>
           </a:p>
         </p:txBody>

</xml_diff>

<commit_message>
docs: add rendered architecture diagram (README + deck)
Co-Authored-By: Claude Opus 4.8 (1M context) <noreply@anthropic.com>
</commit_message>
<xml_diff>
--- a/deliverables/presentation.pptx
+++ b/deliverables/presentation.pptx
@@ -14,6 +14,7 @@
     <p:sldId id="256" r:id="rId14"/>
     <p:sldId id="257" r:id="rId15"/>
     <p:sldId id="258" r:id="rId16"/>
+    <p:sldId id="274" r:id="rId6"/>
     <p:sldId id="259" r:id="rId17"/>
     <p:sldId id="260" r:id="rId18"/>
     <p:sldId id="261" r:id="rId19"/>
@@ -41445,6 +41446,69 @@
 </p:sld>
 </file>
 
+<file path=ppt/slides/slide19.xml><?xml version="1.0" encoding="utf-8"?>
+<p:sld xmlns:a="http://schemas.openxmlformats.org/drawingml/2006/main" xmlns:p="http://schemas.openxmlformats.org/presentationml/2006/main" xmlns:r="http://schemas.openxmlformats.org/officeDocument/2006/relationships">
+  <p:cSld>
+    <p:spTree>
+      <p:nvGrpSpPr>
+        <p:cNvPr id="1" name=""/>
+        <p:cNvGrpSpPr/>
+        <p:nvPr/>
+      </p:nvGrpSpPr>
+      <p:grpSpPr/>
+      <p:sp>
+        <p:nvSpPr>
+          <p:cNvPr id="2" name="Title 1"/>
+          <p:cNvSpPr>
+            <a:spLocks noGrp="1"/>
+          </p:cNvSpPr>
+          <p:nvPr>
+            <p:ph type="title"/>
+          </p:nvPr>
+        </p:nvSpPr>
+        <p:spPr/>
+        <p:txBody>
+          <a:bodyPr/>
+          <a:lstStyle/>
+          <a:p>
+            <a:r>
+              <a:t>Architecture</a:t>
+            </a:r>
+          </a:p>
+        </p:txBody>
+      </p:sp>
+      <p:pic>
+        <p:nvPicPr>
+          <p:cNvPr id="3" name="Picture 2" descr="architecture.png"/>
+          <p:cNvPicPr>
+            <a:picLocks noChangeAspect="1"/>
+          </p:cNvPicPr>
+          <p:nvPr/>
+        </p:nvPicPr>
+        <p:blipFill>
+          <a:blip r:embed="rId2"/>
+          <a:stretch>
+            <a:fillRect/>
+          </a:stretch>
+        </p:blipFill>
+        <p:spPr>
+          <a:xfrm>
+            <a:off x="457200" y="1965883"/>
+            <a:ext cx="11277600" cy="3932073"/>
+          </a:xfrm>
+          <a:prstGeom prst="rect">
+            <a:avLst/>
+          </a:prstGeom>
+        </p:spPr>
+      </p:pic>
+    </p:spTree>
+  </p:cSld>
+  <p:clrMapOvr>
+    <a:masterClrMapping/>
+  </p:clrMapOvr>
+</p:sld>
+</file>
+
 <file path=ppt/slides/slide2.xml><?xml version="1.0" encoding="utf-8"?>
 <p:sld xmlns:r="http://schemas.openxmlformats.org/officeDocument/2006/relationships" xmlns:a="http://schemas.openxmlformats.org/drawingml/2006/main" xmlns:p="http://schemas.openxmlformats.org/presentationml/2006/main">
   <p:cSld>

</xml_diff>

<commit_message>
Fix Bloc 4 deck: integer EMU coordinates so PowerPoint opens it without the content-repair error (fractional EMU on the drift-loop slide)
Co-Authored-By: Claude Opus 4.8 (1M context) <noreply@anthropic.com>
</commit_message>
<xml_diff>
--- a/deliverables/presentation.pptx
+++ b/deliverables/presentation.pptx
@@ -6980,8 +6980,8 @@
         </p:nvCxnSpPr>
         <p:spPr>
           <a:xfrm>
-            <a:off x="1440179.5" y="3063240"/>
-            <a:ext cx="8618220.5" cy="0"/>
+            <a:off x="1440179" y="3063240"/>
+            <a:ext cx="8618221" cy="0"/>
           </a:xfrm>
           <a:prstGeom prst="line">
             <a:avLst/>
@@ -7003,8 +7003,8 @@
         </p:nvCxnSpPr>
         <p:spPr>
           <a:xfrm flipV="1">
-            <a:off x="1440179.5" y="2651760"/>
-            <a:ext cx="0.0" cy="411480"/>
+            <a:off x="1440179" y="2651760"/>
+            <a:ext cx="0" cy="411480"/>
           </a:xfrm>
           <a:prstGeom prst="line">
             <a:avLst/>

</xml_diff>